<commit_message>
feat: complete BCS753 presentation, white-background diagrams, centered page footers, and official cover page format
</commit_message>
<xml_diff>
--- a/BCS753_Major_Project_Presentation_FINAL.pptx
+++ b/BCS753_Major_Project_Presentation_FINAL.pptx
@@ -4114,53 +4114,15 @@
           </a:bodyPr>
           <a:lstStyle/>
           <a:p>
-            <a:pPr indent="0" lvl="0" marL="0" marR="0" rtl="0" algn="ctr">
-              <a:spcBef>
-                <a:spcPts val="0"/>
-              </a:spcBef>
-              <a:spcAft>
-                <a:spcPts val="0"/>
-              </a:spcAft>
-              <a:buClr>
-                <a:srgbClr val="FFFFFF"/>
-              </a:buClr>
-              <a:buSzPts val="3200"/>
-              <a:buFont typeface="Cambria"/>
-              <a:buNone/>
-            </a:pPr>
-            <a:r>
-              <a:rPr sz="2600" b="1">
+            <a:pPr algn="l"/>
+            <a:r>
+              <a:rPr sz="2000" b="1">
                 <a:solidFill>
                   <a:srgbClr val="FFFFFF"/>
-                </a:solidFill>
-                <a:latin typeface="Trebuchet MS"/>
-              </a:rPr>
-              <a:t>Dual-Stream Spatial &amp; Frequency-Domain Deepfake Video Detection</a:t>
-            </a:r>
-            <a:endParaRPr b="0" i="0" sz="3000" u="none" cap="none" strike="noStrike">
-              <a:solidFill>
-                <a:schemeClr val="dk1"/>
-              </a:solidFill>
-              <a:latin typeface="Calibri"/>
-              <a:ea typeface="Calibri"/>
-              <a:cs typeface="Calibri"/>
-              <a:sym typeface="Calibri"/>
-            </a:endParaRPr>
-          </a:p>
-          <a:p>
-            <a:pPr algn="ctr">
-              <a:spcBef>
-                <a:spcPts val="800"/>
-              </a:spcBef>
-            </a:pPr>
-            <a:r>
-              <a:rPr sz="1300" b="0">
-                <a:solidFill>
-                  <a:srgbClr val="00D4FF"/>
                 </a:solidFill>
                 <a:latin typeface="Calibri"/>
               </a:rPr>
-              <a:t>Leveraging EfficientNet-B4, 2D-DCT Spectral Analysis &amp; Attention-Gated Bilinear Fusion</a:t>
+              <a:t>DUAL-STREAM SPATIAL AND FREQUENCY-DOMAIN DEEPFAKE VIDEO DETECTION USING EFFICIENTNET-B4 AND DISCRETE COSINE TRANSFORM (DCT)</a:t>
             </a:r>
           </a:p>
         </p:txBody>
@@ -4190,41 +4152,15 @@
           </a:bodyPr>
           <a:lstStyle/>
           <a:p>
-            <a:pPr indent="0" lvl="0" marL="0" marR="0" rtl="0" algn="ctr">
-              <a:spcBef>
-                <a:spcPts val="0"/>
-              </a:spcBef>
-              <a:spcAft>
-                <a:spcPts val="0"/>
-              </a:spcAft>
-              <a:buClr>
-                <a:srgbClr val="CFE3EE"/>
-              </a:buClr>
-              <a:buSzPts val="1300"/>
-              <a:buFont typeface="Calibri"/>
-              <a:buNone/>
-            </a:pPr>
-            <a:r>
-              <a:rPr b="0" i="1" lang="en-US" sz="1500" u="none" cap="none" strike="noStrike">
-                <a:solidFill>
-                  <a:srgbClr val="CFE3EE"/>
+            <a:r>
+              <a:rPr sz="1300">
+                <a:solidFill>
+                  <a:srgbClr val="C8D7E6"/>
                 </a:solidFill>
                 <a:latin typeface="Calibri"/>
-                <a:ea typeface="Calibri"/>
-                <a:cs typeface="Calibri"/>
-                <a:sym typeface="Calibri"/>
               </a:rPr>
-              <a:t>Project Presentation – I   |   Session 2026–27</a:t>
-            </a:r>
-            <a:endParaRPr b="0" i="0" sz="1500" u="none" cap="none" strike="noStrike">
-              <a:solidFill>
-                <a:schemeClr val="dk1"/>
-              </a:solidFill>
-              <a:latin typeface="Calibri"/>
-              <a:ea typeface="Calibri"/>
-              <a:cs typeface="Calibri"/>
-              <a:sym typeface="Calibri"/>
-            </a:endParaRPr>
+              <a:t>Project Presentation - I   |   Session 2026-27</a:t>
+            </a:r>
           </a:p>
         </p:txBody>
       </p:sp>
@@ -4344,22 +4280,8 @@
           </a:bodyPr>
           <a:lstStyle/>
           <a:p>
-            <a:pPr indent="0" lvl="0" marL="0" marR="0" rtl="0" algn="l">
-              <a:spcBef>
-                <a:spcPts val="0"/>
-              </a:spcBef>
-              <a:spcAft>
-                <a:spcPts val="0"/>
-              </a:spcAft>
-              <a:buClr>
-                <a:srgbClr val="FFFFFF"/>
-              </a:buClr>
-              <a:buSzPts val="1500"/>
-              <a:buFont typeface="Calibri"/>
-              <a:buNone/>
-            </a:pPr>
-            <a:r>
-              <a:rPr sz="1400" b="1">
+            <a:r>
+              <a:rPr sz="1300" b="1">
                 <a:solidFill>
                   <a:srgbClr val="FFFFFF"/>
                 </a:solidFill>
@@ -4367,15 +4289,6 @@
               </a:rPr>
               <a:t>Dr. Devendra Gautam</a:t>
             </a:r>
-            <a:endParaRPr b="0" i="0" u="none" cap="none" strike="noStrike">
-              <a:solidFill>
-                <a:schemeClr val="dk1"/>
-              </a:solidFill>
-              <a:latin typeface="Calibri"/>
-              <a:ea typeface="Calibri"/>
-              <a:cs typeface="Calibri"/>
-              <a:sym typeface="Calibri"/>
-            </a:endParaRPr>
           </a:p>
         </p:txBody>
       </p:sp>
@@ -4404,38 +4317,15 @@
           </a:bodyPr>
           <a:lstStyle/>
           <a:p>
-            <a:pPr indent="0" lvl="0" marL="0" marR="0" rtl="0" algn="l">
-              <a:spcBef>
-                <a:spcPts val="0"/>
-              </a:spcBef>
-              <a:spcAft>
-                <a:spcPts val="0"/>
-              </a:spcAft>
-              <a:buClr>
-                <a:srgbClr val="CFE3EE"/>
-              </a:buClr>
-              <a:buSzPts val="1100"/>
-              <a:buFont typeface="Calibri"/>
-              <a:buNone/>
-            </a:pPr>
-            <a:r>
-              <a:rPr sz="1150" b="0">
-                <a:solidFill>
-                  <a:srgbClr val="94A3B8"/>
+            <a:r>
+              <a:rPr sz="1100">
+                <a:solidFill>
+                  <a:srgbClr val="B4C8DC"/>
                 </a:solidFill>
                 <a:latin typeface="Calibri"/>
               </a:rPr>
-              <a:t>Associate Professor &amp; Mini Project Coordinator, Department of CSE</a:t>
-            </a:r>
-            <a:endParaRPr b="0" i="0" sz="1200" u="none" cap="none" strike="noStrike">
-              <a:solidFill>
-                <a:schemeClr val="dk1"/>
-              </a:solidFill>
-              <a:latin typeface="Calibri"/>
-              <a:ea typeface="Calibri"/>
-              <a:cs typeface="Calibri"/>
-              <a:sym typeface="Calibri"/>
-            </a:endParaRPr>
+              <a:t>Associate Professor, Department of CSE</a:t>
+            </a:r>
           </a:p>
         </p:txBody>
       </p:sp>
@@ -4527,51 +4417,14 @@
           </a:bodyPr>
           <a:lstStyle/>
           <a:p>
-            <a:pPr indent="0" lvl="0" marL="0" marR="0" rtl="0" algn="l">
-              <a:lnSpc>
-                <a:spcPct val="135000"/>
-              </a:lnSpc>
-              <a:spcBef>
-                <a:spcPts val="0"/>
-              </a:spcBef>
-              <a:spcAft>
-                <a:spcPts val="400"/>
-              </a:spcAft>
-              <a:buClr>
-                <a:srgbClr val="FFFFFF"/>
-              </a:buClr>
-              <a:buSzPts val="1150"/>
-              <a:buFont typeface="Calibri"/>
-              <a:buNone/>
-            </a:pPr>
-            <a:r>
-              <a:rPr sz="1300" b="1">
+            <a:r>
+              <a:rPr sz="1200">
                 <a:solidFill>
                   <a:srgbClr val="FFFFFF"/>
                 </a:solidFill>
                 <a:latin typeface="Calibri"/>
               </a:rPr>
-              <a:t>Dev Rana Kaila   —   Roll No. 2301531530023   —   Sec A   (AIML)</a:t>
-            </a:r>
-            <a:endParaRPr b="0" i="0" sz="1250" u="none" cap="none" strike="noStrike">
-              <a:solidFill>
-                <a:schemeClr val="dk1"/>
-              </a:solidFill>
-              <a:latin typeface="Calibri"/>
-              <a:ea typeface="Calibri"/>
-              <a:cs typeface="Calibri"/>
-              <a:sym typeface="Calibri"/>
-            </a:endParaRPr>
-          </a:p>
-          <a:p>
-            <a:r>
-              <a:rPr sz="1100" b="0">
-                <a:solidFill>
-                  <a:srgbClr val="94A3B8"/>
-                </a:solidFill>
-                <a:latin typeface="Calibri"/>
-              </a:rPr>
-              <a:t>B.Tech Computer Science &amp; Engineering (Artificial Intelligence &amp; Machine Learning), 7th Semester</a:t>
+              <a:t>Dev Rana Kaila   |   Roll No. 2301531530023   |   B.Tech CSE (AIML), 7th Sem, Sec A</a:t>
             </a:r>
           </a:p>
         </p:txBody>
@@ -7038,88 +6891,117 @@
           </a:bodyPr>
           <a:lstStyle/>
           <a:p>
-            <a:pPr indent="0" lvl="0" marL="0" marR="0" rtl="0" algn="l">
-              <a:lnSpc>
-                <a:spcPct val="130000"/>
-              </a:lnSpc>
-              <a:spcBef>
-                <a:spcPts val="0"/>
-              </a:spcBef>
-              <a:spcAft>
-                <a:spcPts val="1000"/>
-              </a:spcAft>
-              <a:buClr>
-                <a:srgbClr val="6B7593"/>
-              </a:buClr>
-              <a:buSzPts val="1400"/>
-              <a:buFont typeface="Calibri"/>
-              <a:buNone/>
-            </a:pPr>
-            <a:r>
-              <a:rPr sz="1250" b="1">
-                <a:solidFill>
-                  <a:srgbClr val="F1F5F9"/>
+            <a:pPr>
+              <a:spcBef>
+                <a:spcPts val="800"/>
+              </a:spcBef>
+              <a:spcAft>
+                <a:spcPts val="200"/>
+              </a:spcAft>
+            </a:pPr>
+            <a:r>
+              <a:rPr sz="1300" b="1">
+                <a:solidFill>
+                  <a:srgbClr val="1A365D"/>
                 </a:solidFill>
                 <a:latin typeface="Calibri"/>
               </a:rPr>
-              <a:t>Deepfake video synthesis powered by Generative Adversarial Networks (GANs) poses catastrophic risks to biometric authentication, digital banking KYC verification, judicial evidence admissibility, and societal information integrity.</a:t>
-            </a:r>
-            <a:endParaRPr b="0" i="0" sz="1400" u="none" cap="none" strike="noStrike">
-              <a:solidFill>
-                <a:schemeClr val="dk1"/>
-              </a:solidFill>
-              <a:latin typeface="Calibri"/>
-              <a:ea typeface="Calibri"/>
-              <a:cs typeface="Calibri"/>
-              <a:sym typeface="Calibri"/>
-            </a:endParaRPr>
+              <a:t>1. Performance Collapse Under Social Media Compression (c23 / c40)</a:t>
+            </a:r>
           </a:p>
           <a:p>
             <a:pPr>
-              <a:spcAft>
-                <a:spcPts val="1000"/>
-              </a:spcAft>
-            </a:pPr>
-            <a:r>
-              <a:rPr sz="1250" b="0">
-                <a:solidFill>
-                  <a:srgbClr val="CBD5E1"/>
+              <a:spcBef>
+                <a:spcPts val="0"/>
+              </a:spcBef>
+              <a:spcAft>
+                <a:spcPts val="600"/>
+              </a:spcAft>
+            </a:pPr>
+            <a:r>
+              <a:rPr sz="1100">
+                <a:solidFill>
+                  <a:srgbClr val="3C3C3C"/>
                 </a:solidFill>
                 <a:latin typeface="Calibri"/>
               </a:rPr>
-              <a:t>Critical Research Gap — The Compression Blind-Spot: State-of-the-art competition solutions, such as Selim Seferbekov's 1st-place Kaggle DFDC model and MesoNet, rely exclusively on pixel-level (spatial) features. Under standard social media compression (H.264 / WhatsApp / YouTube), subtle pixel manipulation clues are smoothed away, causing spatial-only detectors to plummet by 20% to 35% in accuracy.</a:t>
+              <a:t>State-of-the-art spatial CNNs (XceptionNet, EfficientNet) rely on high-frequency pixel textures (blending edges, color mismatches). When deepfakes are shared across WhatsApp, YouTube, or Twitter, lossy H.264/H.265 compression obliterates these subtle visual artifacts, causing detection accuracy to drop catastrophically from 98% down to 65-70%.</a:t>
             </a:r>
           </a:p>
           <a:p>
             <a:pPr>
-              <a:spcAft>
-                <a:spcPts val="1000"/>
-              </a:spcAft>
-            </a:pPr>
-            <a:r>
-              <a:rPr sz="1250" b="0">
-                <a:solidFill>
-                  <a:srgbClr val="CBD5E1"/>
+              <a:spcBef>
+                <a:spcPts val="800"/>
+              </a:spcBef>
+              <a:spcAft>
+                <a:spcPts val="200"/>
+              </a:spcAft>
+            </a:pPr>
+            <a:r>
+              <a:rPr sz="1300" b="1">
+                <a:solidFill>
+                  <a:srgbClr val="1A365D"/>
                 </a:solidFill>
                 <a:latin typeface="Calibri"/>
               </a:rPr>
-              <a:t>The Frequency Solution: Convolutional GAN generators leave persistent periodic checkerboard artifacts in the frequency domain due to transposed upsampling operations. Unlike spatial pixels, these mathematical spectral fingerprints survive heavy lossy video compression.</a:t>
+              <a:t>2. Imperceptible Spectral Fingerprints Left by Generative Upsampling</a:t>
             </a:r>
           </a:p>
           <a:p>
             <a:pPr>
-              <a:spcAft>
-                <a:spcPts val="1000"/>
-              </a:spcAft>
-            </a:pPr>
-            <a:r>
-              <a:rPr sz="1250" b="0">
-                <a:solidFill>
-                  <a:srgbClr val="CBD5E1"/>
+              <a:spcBef>
+                <a:spcPts val="0"/>
+              </a:spcBef>
+              <a:spcAft>
+                <a:spcPts val="600"/>
+              </a:spcAft>
+            </a:pPr>
+            <a:r>
+              <a:rPr sz="1100">
+                <a:solidFill>
+                  <a:srgbClr val="3C3C3C"/>
                 </a:solidFill>
                 <a:latin typeface="Calibri"/>
               </a:rPr>
-              <a:t>The Forensic Opacity Problem: Existing deployed models operate as uninterpretable black boxes outputting only a scalar probability, making them inadmissible in courtrooms and non-compliant with explainable AI (XAI) mandates.</a:t>
+              <a:t>Generative models (GANs, Autoencoders, Diffusion) employ transposed convolutions and bilinear interpolation during upsampling. These operations introduce mathematical, periodic grid discrepancies (spectral anomalies) in the frequency domain that are entirely invisible in the RGB pixel space but persist even after heavy lossy compression.</a:t>
+            </a:r>
+          </a:p>
+          <a:p>
+            <a:pPr>
+              <a:spcBef>
+                <a:spcPts val="800"/>
+              </a:spcBef>
+              <a:spcAft>
+                <a:spcPts val="200"/>
+              </a:spcAft>
+            </a:pPr>
+            <a:r>
+              <a:rPr sz="1300" b="1">
+                <a:solidFill>
+                  <a:srgbClr val="1A365D"/>
+                </a:solidFill>
+                <a:latin typeface="Calibri"/>
+              </a:rPr>
+              <a:t>3. Lack of Explainability &amp; Real-Time Operational Latency</a:t>
+            </a:r>
+          </a:p>
+          <a:p>
+            <a:pPr>
+              <a:spcBef>
+                <a:spcPts val="0"/>
+              </a:spcBef>
+              <a:spcAft>
+                <a:spcPts val="600"/>
+              </a:spcAft>
+            </a:pPr>
+            <a:r>
+              <a:rPr sz="1100">
+                <a:solidFill>
+                  <a:srgbClr val="3C3C3C"/>
+                </a:solidFill>
+                <a:latin typeface="Calibri"/>
+              </a:rPr>
+              <a:t>Current forensic tools operate as uninterpretable 'black-boxes', providing raw classification scores without localized visual evidence required in forensic audits and legal proceedings (e.g., Section 65B Indian Evidence Act). Furthermore, monolithic heavyweight architectures exceed 250ms/frame, preventing real-time verification.</a:t>
             </a:r>
           </a:p>
         </p:txBody>
@@ -7745,38 +7627,20 @@
           </a:bodyPr>
           <a:lstStyle/>
           <a:p>
-            <a:pPr indent="0" lvl="0" marL="0" marR="0" rtl="0" algn="l">
-              <a:spcBef>
-                <a:spcPts val="0"/>
-              </a:spcBef>
-              <a:spcAft>
-                <a:spcPts val="0"/>
-              </a:spcAft>
-              <a:buClr>
-                <a:srgbClr val="1B1F3B"/>
-              </a:buClr>
-              <a:buSzPts val="1300"/>
-              <a:buFont typeface="Calibri"/>
-              <a:buNone/>
-            </a:pPr>
-            <a:r>
-              <a:rPr sz="1050" b="0">
-                <a:solidFill>
-                  <a:srgbClr val="E2E8F0"/>
-                </a:solidFill>
+            <a:r>
+              <a:rPr sz="1050">
                 <a:latin typeface="Calibri"/>
               </a:rPr>
-              <a:t>Automate continuous video ingestion, uniform frame sampling at 5 FPS, and MTCNN face detection with a 15% contextual boundary margin to generate canonical 256×256 aligned face crops.</a:t>
-            </a:r>
-            <a:endParaRPr b="0" i="0" sz="1300" u="none" cap="none" strike="noStrike">
-              <a:solidFill>
-                <a:schemeClr val="dk1"/>
-              </a:solidFill>
-              <a:latin typeface="Calibri"/>
-              <a:ea typeface="Calibri"/>
-              <a:cs typeface="Calibri"/>
-              <a:sym typeface="Calibri"/>
-            </a:endParaRPr>
+              <a:t>Dual-Stream Feature Extraction</a:t>
+            </a:r>
+          </a:p>
+          <a:p>
+            <a:r>
+              <a:rPr sz="1050">
+                <a:latin typeface="Calibri"/>
+              </a:rPr>
+              <a:t>Engineer a dual-branch neural architecture extracting spatial RGB visual artifacts (EfficientNet-B4, 1792-d) and orthogonal frequency spectral anomalies (2D-DCT-II + Spectral-CNN, 512-d).</a:t>
+            </a:r>
           </a:p>
         </p:txBody>
       </p:sp>
@@ -7919,38 +7783,20 @@
           </a:bodyPr>
           <a:lstStyle/>
           <a:p>
-            <a:pPr indent="0" lvl="0" marL="0" marR="0" rtl="0" algn="l">
-              <a:spcBef>
-                <a:spcPts val="0"/>
-              </a:spcBef>
-              <a:spcAft>
-                <a:spcPts val="0"/>
-              </a:spcAft>
-              <a:buClr>
-                <a:srgbClr val="1B1F3B"/>
-              </a:buClr>
-              <a:buSzPts val="1300"/>
-              <a:buFont typeface="Calibri"/>
-              <a:buNone/>
-            </a:pPr>
-            <a:r>
-              <a:rPr sz="1050" b="0">
-                <a:solidFill>
-                  <a:srgbClr val="E2E8F0"/>
-                </a:solidFill>
+            <a:r>
+              <a:rPr sz="1050">
                 <a:latin typeface="Calibri"/>
               </a:rPr>
-              <a:t>Design a dual-stream neural architecture combining an EfficientNet-B4 spatial backbone (1,792-d) and a 2D-DCT Spectral CNN (512-d) to capture orthogonal pixel and frequency clues concurrently.</a:t>
-            </a:r>
-            <a:endParaRPr b="0" i="0" sz="1300" u="none" cap="none" strike="noStrike">
-              <a:solidFill>
-                <a:schemeClr val="dk1"/>
-              </a:solidFill>
-              <a:latin typeface="Calibri"/>
-              <a:ea typeface="Calibri"/>
-              <a:cs typeface="Calibri"/>
-              <a:sym typeface="Calibri"/>
-            </a:endParaRPr>
+              <a:t>Attention-Gated Cross-Domain Fusion</a:t>
+            </a:r>
+          </a:p>
+          <a:p>
+            <a:r>
+              <a:rPr sz="1050">
+                <a:latin typeface="Calibri"/>
+              </a:rPr>
+              <a:t>Implement an adaptive bilinear fusion gate that dynamically balances spatial vs frequency representations, shifting trust toward spectral features under severe video compression.</a:t>
+            </a:r>
           </a:p>
         </p:txBody>
       </p:sp>
@@ -8093,38 +7939,20 @@
           </a:bodyPr>
           <a:lstStyle/>
           <a:p>
-            <a:pPr indent="0" lvl="0" marL="0" marR="0" rtl="0" algn="l">
-              <a:spcBef>
-                <a:spcPts val="0"/>
-              </a:spcBef>
-              <a:spcAft>
-                <a:spcPts val="0"/>
-              </a:spcAft>
-              <a:buClr>
-                <a:srgbClr val="1B1F3B"/>
-              </a:buClr>
-              <a:buSzPts val="1300"/>
-              <a:buFont typeface="Calibri"/>
-              <a:buNone/>
-            </a:pPr>
-            <a:r>
-              <a:rPr sz="1050" b="0">
-                <a:solidFill>
-                  <a:srgbClr val="E2E8F0"/>
-                </a:solidFill>
+            <a:r>
+              <a:rPr sz="1050">
                 <a:latin typeface="Calibri"/>
               </a:rPr>
-              <a:t>Formulate a rotationally invariant Radial Azimuthal DCT Spectrum A(r) and an Attention-Gated Bilinear Fusion mechanism g = σ(Wg·[vs ∥ vf] + bg) to dynamically weight streams under compression.</a:t>
-            </a:r>
-            <a:endParaRPr b="0" i="0" sz="1300" u="none" cap="none" strike="noStrike">
-              <a:solidFill>
-                <a:schemeClr val="dk1"/>
-              </a:solidFill>
-              <a:latin typeface="Calibri"/>
-              <a:ea typeface="Calibri"/>
-              <a:cs typeface="Calibri"/>
-              <a:sym typeface="Calibri"/>
-            </a:endParaRPr>
+              <a:t>Synchronized Explainability (XAI)</a:t>
+            </a:r>
+          </a:p>
+          <a:p>
+            <a:r>
+              <a:rPr sz="1050">
+                <a:latin typeface="Calibri"/>
+              </a:rPr>
+              <a:t>Integrate dual-branch Grad-CAM localization to generate heatmaps highlighting spatial boundary manipulation and spectral frequency artifact clusters for forensic auditability.</a:t>
+            </a:r>
           </a:p>
         </p:txBody>
       </p:sp>
@@ -8267,38 +8095,20 @@
           </a:bodyPr>
           <a:lstStyle/>
           <a:p>
-            <a:pPr indent="0" lvl="0" marL="0" marR="0" rtl="0" algn="l">
-              <a:spcBef>
-                <a:spcPts val="0"/>
-              </a:spcBef>
-              <a:spcAft>
-                <a:spcPts val="0"/>
-              </a:spcAft>
-              <a:buClr>
-                <a:srgbClr val="1B1F3B"/>
-              </a:buClr>
-              <a:buSzPts val="1300"/>
-              <a:buFont typeface="Calibri"/>
-              <a:buNone/>
-            </a:pPr>
-            <a:r>
-              <a:rPr sz="1050" b="0">
-                <a:solidFill>
-                  <a:srgbClr val="E2E8F0"/>
-                </a:solidFill>
+            <a:r>
+              <a:rPr sz="1050">
                 <a:latin typeface="Calibri"/>
               </a:rPr>
-              <a:t>Implement Grad-CAM forensic explainability to produce visual saliency heatmaps for courtroom admissibility, and deploy the pipeline via a real-time interactive Streamlit web dashboard.</a:t>
-            </a:r>
-            <a:endParaRPr b="0" i="0" sz="1300" u="none" cap="none" strike="noStrike">
-              <a:solidFill>
-                <a:schemeClr val="dk1"/>
-              </a:solidFill>
-              <a:latin typeface="Calibri"/>
-              <a:ea typeface="Calibri"/>
-              <a:cs typeface="Calibri"/>
-              <a:sym typeface="Calibri"/>
-            </a:endParaRPr>
+              <a:t>Real-Time Web Forensic Portal</a:t>
+            </a:r>
+          </a:p>
+          <a:p>
+            <a:r>
+              <a:rPr sz="1050">
+                <a:latin typeface="Calibri"/>
+              </a:rPr>
+              <a:t>Deploy a production Streamlit web application delivering &lt; 50ms/frame inference, interactive Plotly authenticity gauges, 30-frame temporal timelines, and certified PDF report export.</a:t>
+            </a:r>
           </a:p>
         </p:txBody>
       </p:sp>
@@ -8774,136 +8584,238 @@
           </a:bodyPr>
           <a:lstStyle/>
           <a:p>
-            <a:pPr indent="0" lvl="0" marL="0" rtl="0" algn="l">
-              <a:spcBef>
-                <a:spcPts val="0"/>
-              </a:spcBef>
-              <a:spcAft>
-                <a:spcPts val="200"/>
-              </a:spcAft>
-              <a:buNone/>
-            </a:pPr>
-            <a:r>
-              <a:rPr sz="1300" b="1">
-                <a:solidFill>
-                  <a:srgbClr val="00D4FF"/>
+            <a:pPr>
+              <a:spcBef>
+                <a:spcPts val="600"/>
+              </a:spcBef>
+              <a:spcAft>
+                <a:spcPts val="100"/>
+              </a:spcAft>
+            </a:pPr>
+            <a:r>
+              <a:rPr sz="1250" b="1">
+                <a:solidFill>
+                  <a:srgbClr val="1A365D"/>
                 </a:solidFill>
                 <a:latin typeface="Calibri"/>
               </a:rPr>
-              <a:t>•  Deep Learning &amp; Modeling: </a:t>
-            </a:r>
-            <a:endParaRPr/>
-          </a:p>
-          <a:p>
-            <a:pPr>
-              <a:spcAft>
-                <a:spcPts val="1000"/>
-              </a:spcAft>
-            </a:pPr>
-            <a:r>
-              <a:rPr sz="1150" b="0">
-                <a:solidFill>
-                  <a:srgbClr val="CBD5E1"/>
+              <a:t>Deep Learning &amp; Model Architecture:  </a:t>
+            </a:r>
+            <a:r>
+              <a:rPr sz="1200" b="1">
+                <a:solidFill>
+                  <a:srgbClr val="BE5014"/>
                 </a:solidFill>
                 <a:latin typeface="Calibri"/>
               </a:rPr>
-              <a:t>   PyTorch 2.6.0 with CUDA 11.8 (GPU acceleration &amp; CPU fallback), timm (PyTorch Image Models) for EfficientNet-B4 pretrained backbone, torchvision.</a:t>
+              <a:t>PyTorch 2.4  |  torchvision  |  timm</a:t>
             </a:r>
           </a:p>
           <a:p>
             <a:pPr>
-              <a:spcAft>
-                <a:spcPts val="200"/>
-              </a:spcAft>
-            </a:pPr>
-            <a:r>
-              <a:rPr sz="1300" b="1">
-                <a:solidFill>
-                  <a:srgbClr val="00D4FF"/>
+              <a:spcBef>
+                <a:spcPts val="0"/>
+              </a:spcBef>
+              <a:spcAft>
+                <a:spcPts val="400"/>
+              </a:spcAft>
+            </a:pPr>
+            <a:r>
+              <a:rPr sz="1050">
+                <a:solidFill>
+                  <a:srgbClr val="464646"/>
                 </a:solidFill>
                 <a:latin typeface="Calibri"/>
               </a:rPr>
-              <a:t>•  Signal Processing &amp; Vision: </a:t>
+              <a:t>EfficientNet-B4 spatial backbone (pretrained ImageNet-1k, 19.3M params), custom 4-stage depthwise separable Spectral-CNN (2.8M params), Bilinear Attention Gate, PyTorch native Mixed Precision (FP16).</a:t>
             </a:r>
           </a:p>
           <a:p>
             <a:pPr>
-              <a:spcAft>
-                <a:spcPts val="1000"/>
-              </a:spcAft>
-            </a:pPr>
-            <a:r>
-              <a:rPr sz="1150" b="0">
-                <a:solidFill>
-                  <a:srgbClr val="CBD5E1"/>
+              <a:spcBef>
+                <a:spcPts val="600"/>
+              </a:spcBef>
+              <a:spcAft>
+                <a:spcPts val="100"/>
+              </a:spcAft>
+            </a:pPr>
+            <a:r>
+              <a:rPr sz="1250" b="1">
+                <a:solidFill>
+                  <a:srgbClr val="1A365D"/>
                 </a:solidFill>
                 <a:latin typeface="Calibri"/>
               </a:rPr>
-              <a:t>   OpenCV 4.8+ (video decoding, temporal frame sampling @ 5 FPS), MTCNN (facenet-pytorch) for cascaded face landmark alignment, SciPy (scipy.fft.dctn) for 2D Discrete Cosine Transform.</a:t>
-            </a:r>
-          </a:p>
-          <a:p>
-            <a:pPr>
-              <a:spcAft>
-                <a:spcPts val="200"/>
-              </a:spcAft>
-            </a:pPr>
-            <a:r>
-              <a:rPr sz="1300" b="1">
-                <a:solidFill>
-                  <a:srgbClr val="00D4FF"/>
+              <a:t>Frequency &amp; Mathematical Transforms:  </a:t>
+            </a:r>
+            <a:r>
+              <a:rPr sz="1200" b="1">
+                <a:solidFill>
+                  <a:srgbClr val="BE5014"/>
                 </a:solidFill>
                 <a:latin typeface="Calibri"/>
               </a:rPr>
-              <a:t>•  Deployment &amp; Visualization: </a:t>
+              <a:t>NumPy  |  SciPy (2D-DCT-II)  |  Fast Fourier Transform (FFT)</a:t>
             </a:r>
           </a:p>
           <a:p>
             <a:pPr>
-              <a:spcAft>
-                <a:spcPts val="1000"/>
-              </a:spcAft>
-            </a:pPr>
-            <a:r>
-              <a:rPr sz="1150" b="0">
-                <a:solidFill>
-                  <a:srgbClr val="CBD5E1"/>
+              <a:spcBef>
+                <a:spcPts val="0"/>
+              </a:spcBef>
+              <a:spcAft>
+                <a:spcPts val="400"/>
+              </a:spcAft>
+            </a:pPr>
+            <a:r>
+              <a:rPr sz="1050">
+                <a:solidFill>
+                  <a:srgbClr val="464646"/>
                 </a:solidFill>
                 <a:latin typeface="Calibri"/>
               </a:rPr>
-              <a:t>   Streamlit 1.30+ for forensic web dashboard, Plotly 5.17+ for interactive confidence gauges and temporal charts, PyTorch-Grad-CAM for saliency heatmaps.</a:t>
+              <a:t>Block-wise and full-frame 2D Discrete Cosine Transform Type-II, Logarithmic power spectrum computation log(1 + |DCT|^2), Radial azimuthal frequency band integration A(r).</a:t>
             </a:r>
           </a:p>
           <a:p>
             <a:pPr>
-              <a:spcAft>
-                <a:spcPts val="200"/>
-              </a:spcAft>
-            </a:pPr>
-            <a:r>
-              <a:rPr sz="1300" b="1">
-                <a:solidFill>
-                  <a:srgbClr val="00D4FF"/>
+              <a:spcBef>
+                <a:spcPts val="600"/>
+              </a:spcBef>
+              <a:spcAft>
+                <a:spcPts val="100"/>
+              </a:spcAft>
+            </a:pPr>
+            <a:r>
+              <a:rPr sz="1250" b="1">
+                <a:solidFill>
+                  <a:srgbClr val="1A365D"/>
                 </a:solidFill>
                 <a:latin typeface="Calibri"/>
               </a:rPr>
-              <a:t>•  Hardware &amp; Environment: </a:t>
-            </a:r>
-          </a:p>
-          <a:p>
-            <a:pPr>
-              <a:spcAft>
-                <a:spcPts val="1000"/>
-              </a:spcAft>
-            </a:pPr>
-            <a:r>
-              <a:rPr sz="1150" b="0">
-                <a:solidFill>
-                  <a:srgbClr val="CBD5E1"/>
+              <a:t>Computer Vision &amp; Ingestion Pipeline:  </a:t>
+            </a:r>
+            <a:r>
+              <a:rPr sz="1200" b="1">
+                <a:solidFill>
+                  <a:srgbClr val="BE5014"/>
                 </a:solidFill>
                 <a:latin typeface="Calibri"/>
               </a:rPr>
-              <a:t>   Python 3.10+ (Anaconda / Miniconda), Windows 11 / Ubuntu 20.04 LTS, 16 GB DDR4 RAM, NVIDIA GeForce GTX/RTX or Intel Core i5/i7 (lightweight 21.4M parameter footprint).</a:t>
+              <a:t>OpenCV (cv2)  |  Facenet-PyTorch MTCNN  |  PIL</a:t>
+            </a:r>
+          </a:p>
+          <a:p>
+            <a:pPr>
+              <a:spcBef>
+                <a:spcPts val="0"/>
+              </a:spcBef>
+              <a:spcAft>
+                <a:spcPts val="400"/>
+              </a:spcAft>
+            </a:pPr>
+            <a:r>
+              <a:rPr sz="1050">
+                <a:solidFill>
+                  <a:srgbClr val="464646"/>
+                </a:solidFill>
+                <a:latin typeface="Calibri"/>
+              </a:rPr>
+              <a:t>Uniform temporal sampling at 5 FPS (30 representative frames / sequence), multi-task cascaded face detection, 5-point facial landmark tracking, 25% boundary expansion margin, and 380x380 affine alignment.</a:t>
+            </a:r>
+          </a:p>
+          <a:p>
+            <a:pPr>
+              <a:spcBef>
+                <a:spcPts val="600"/>
+              </a:spcBef>
+              <a:spcAft>
+                <a:spcPts val="100"/>
+              </a:spcAft>
+            </a:pPr>
+            <a:r>
+              <a:rPr sz="1250" b="1">
+                <a:solidFill>
+                  <a:srgbClr val="1A365D"/>
+                </a:solidFill>
+                <a:latin typeface="Calibri"/>
+              </a:rPr>
+              <a:t>Explainable Artificial Intelligence (XAI):  </a:t>
+            </a:r>
+            <a:r>
+              <a:rPr sz="1200" b="1">
+                <a:solidFill>
+                  <a:srgbClr val="BE5014"/>
+                </a:solidFill>
+                <a:latin typeface="Calibri"/>
+              </a:rPr>
+              <a:t>PyTorch Grad-CAM  |  Captum  |  Matplotlib</a:t>
+            </a:r>
+          </a:p>
+          <a:p>
+            <a:pPr>
+              <a:spcBef>
+                <a:spcPts val="0"/>
+              </a:spcBef>
+              <a:spcAft>
+                <a:spcPts val="400"/>
+              </a:spcAft>
+            </a:pPr>
+            <a:r>
+              <a:rPr sz="1050">
+                <a:solidFill>
+                  <a:srgbClr val="464646"/>
+                </a:solidFill>
+                <a:latin typeface="Calibri"/>
+              </a:rPr>
+              <a:t>Gradient-weighted Class Activation Mapping computed from EfficientNet-B4 'conv_head' and Spectral-CNN Stage-4 layers; synchronized spatial and frequency heatmap overlays.</a:t>
+            </a:r>
+          </a:p>
+          <a:p>
+            <a:pPr>
+              <a:spcBef>
+                <a:spcPts val="600"/>
+              </a:spcBef>
+              <a:spcAft>
+                <a:spcPts val="100"/>
+              </a:spcAft>
+            </a:pPr>
+            <a:r>
+              <a:rPr sz="1250" b="1">
+                <a:solidFill>
+                  <a:srgbClr val="1A365D"/>
+                </a:solidFill>
+                <a:latin typeface="Calibri"/>
+              </a:rPr>
+              <a:t>Presentation &amp; Forensic Dashboard:  </a:t>
+            </a:r>
+            <a:r>
+              <a:rPr sz="1200" b="1">
+                <a:solidFill>
+                  <a:srgbClr val="BE5014"/>
+                </a:solidFill>
+                <a:latin typeface="Calibri"/>
+              </a:rPr>
+              <a:t>Streamlit  |  Plotly  |  ReportLab / FPDF</a:t>
+            </a:r>
+          </a:p>
+          <a:p>
+            <a:pPr>
+              <a:spcBef>
+                <a:spcPts val="0"/>
+              </a:spcBef>
+              <a:spcAft>
+                <a:spcPts val="400"/>
+              </a:spcAft>
+            </a:pPr>
+            <a:r>
+              <a:rPr sz="1050">
+                <a:solidFill>
+                  <a:srgbClr val="464646"/>
+                </a:solidFill>
+                <a:latin typeface="Calibri"/>
+              </a:rPr>
+              <a:t>Dark Navy / Cyan interactive forensic web dashboard, animated radial authenticity gauge, 30-frame temporal confidence trajectory curve, side-by-side XAI inspector, and certified evidentiary PDF report generation.</a:t>
             </a:r>
           </a:p>
         </p:txBody>
@@ -9435,9 +9347,9 @@
                         <a:buNone/>
                       </a:pPr>
                       <a:r>
-                        <a:rPr b="1" lang="en-US" sz="950" u="none" cap="none" strike="noStrike">
+                        <a:rPr b="1" lang="en-US" sz="1150" u="none" cap="none" strike="noStrike">
                           <a:solidFill>
-                            <a:srgbClr val="F1F5F9"/>
+                            <a:srgbClr val="FFFFFF"/>
                           </a:solidFill>
                           <a:latin typeface="Calibri"/>
                           <a:ea typeface="Calibri"/>
@@ -9516,9 +9428,9 @@
                         <a:buNone/>
                       </a:pPr>
                       <a:r>
-                        <a:rPr b="0" lang="en-US" sz="950" u="none" cap="none" strike="noStrike">
+                        <a:rPr b="1" lang="en-US" sz="1150" u="none" cap="none" strike="noStrike">
                           <a:solidFill>
-                            <a:srgbClr val="F1F5F9"/>
+                            <a:srgbClr val="FFFFFF"/>
                           </a:solidFill>
                           <a:latin typeface="Calibri"/>
                           <a:ea typeface="Calibri"/>
@@ -9597,9 +9509,9 @@
                         <a:buNone/>
                       </a:pPr>
                       <a:r>
-                        <a:rPr b="0" lang="en-US" sz="950" u="none" cap="none" strike="noStrike">
+                        <a:rPr b="1" lang="en-US" sz="1150" u="none" cap="none" strike="noStrike">
                           <a:solidFill>
-                            <a:srgbClr val="F1F5F9"/>
+                            <a:srgbClr val="FFFFFF"/>
                           </a:solidFill>
                           <a:latin typeface="Calibri"/>
                           <a:ea typeface="Calibri"/>
@@ -9678,9 +9590,9 @@
                         <a:buNone/>
                       </a:pPr>
                       <a:r>
-                        <a:rPr b="0" lang="en-US" sz="950" u="none" cap="none" strike="noStrike">
+                        <a:rPr b="1" lang="en-US" sz="1150" u="none" cap="none" strike="noStrike">
                           <a:solidFill>
-                            <a:srgbClr val="F1F5F9"/>
+                            <a:srgbClr val="FFFFFF"/>
                           </a:solidFill>
                           <a:latin typeface="Calibri"/>
                           <a:ea typeface="Calibri"/>
@@ -9759,9 +9671,9 @@
                         <a:buNone/>
                       </a:pPr>
                       <a:r>
-                        <a:rPr b="0" lang="en-US" sz="950" u="none" cap="none" strike="noStrike">
+                        <a:rPr b="1" lang="en-US" sz="1150" u="none" cap="none" strike="noStrike">
                           <a:solidFill>
-                            <a:srgbClr val="F1F5F9"/>
+                            <a:srgbClr val="FFFFFF"/>
                           </a:solidFill>
                           <a:latin typeface="Calibri"/>
                           <a:ea typeface="Calibri"/>
@@ -9827,11 +9739,16 @@
                     <a:bodyPr/>
                     <a:lstStyle/>
                     <a:p>
+                      <a:pPr>
+                        <a:spcBef>
+                          <a:spcPts val="200"/>
+                        </a:spcBef>
+                        <a:spcAft>
+                          <a:spcPts val="200"/>
+                        </a:spcAft>
+                      </a:pPr>
                       <a:r>
-                        <a:rPr sz="950" b="1">
-                          <a:solidFill>
-                            <a:srgbClr val="F1F5F9"/>
-                          </a:solidFill>
+                        <a:rPr sz="900" b="1">
                           <a:latin typeface="Calibri"/>
                         </a:rPr>
                         <a:t>[1]</a:t>
@@ -9885,11 +9802,16 @@
                     <a:bodyPr/>
                     <a:lstStyle/>
                     <a:p>
+                      <a:pPr>
+                        <a:spcBef>
+                          <a:spcPts val="200"/>
+                        </a:spcBef>
+                        <a:spcAft>
+                          <a:spcPts val="200"/>
+                        </a:spcAft>
+                      </a:pPr>
                       <a:r>
-                        <a:rPr sz="950" b="0">
-                          <a:solidFill>
-                            <a:srgbClr val="F1F5F9"/>
-                          </a:solidFill>
+                        <a:rPr sz="900">
                           <a:latin typeface="Calibri"/>
                         </a:rPr>
                         <a:t>FaceForensics++: Learning to Detect Manipulated Facial Images</a:t>
@@ -9943,14 +9865,19 @@
                     <a:bodyPr/>
                     <a:lstStyle/>
                     <a:p>
+                      <a:pPr>
+                        <a:spcBef>
+                          <a:spcPts val="200"/>
+                        </a:spcBef>
+                        <a:spcAft>
+                          <a:spcPts val="200"/>
+                        </a:spcAft>
+                      </a:pPr>
                       <a:r>
-                        <a:rPr sz="950" b="0">
-                          <a:solidFill>
-                            <a:srgbClr val="F1F5F9"/>
-                          </a:solidFill>
+                        <a:rPr sz="900">
                           <a:latin typeface="Calibri"/>
                         </a:rPr>
-                        <a:t>Rossler et al.</a:t>
+                        <a:t>A. Rössler, D. Cozzolino, et al.</a:t>
                       </a:r>
                     </a:p>
                   </a:txBody>
@@ -10001,11 +9928,16 @@
                     <a:bodyPr/>
                     <a:lstStyle/>
                     <a:p>
+                      <a:pPr>
+                        <a:spcBef>
+                          <a:spcPts val="200"/>
+                        </a:spcBef>
+                        <a:spcAft>
+                          <a:spcPts val="200"/>
+                        </a:spcAft>
+                      </a:pPr>
                       <a:r>
-                        <a:rPr sz="950" b="0">
-                          <a:solidFill>
-                            <a:srgbClr val="F1F5F9"/>
-                          </a:solidFill>
+                        <a:rPr sz="900">
                           <a:latin typeface="Calibri"/>
                         </a:rPr>
                         <a:t>IEEE ICCV, 2019</a:t>
@@ -10059,14 +9991,19 @@
                     <a:bodyPr/>
                     <a:lstStyle/>
                     <a:p>
+                      <a:pPr>
+                        <a:spcBef>
+                          <a:spcPts val="200"/>
+                        </a:spcBef>
+                        <a:spcAft>
+                          <a:spcPts val="200"/>
+                        </a:spcAft>
+                      </a:pPr>
                       <a:r>
-                        <a:rPr sz="950" b="0">
-                          <a:solidFill>
-                            <a:srgbClr val="F1F5F9"/>
-                          </a:solidFill>
+                        <a:rPr sz="900">
                           <a:latin typeface="Calibri"/>
                         </a:rPr>
-                        <a:t>Established FF++ benchmark; showed spatial detectors drop 20-35% in accuracy under c23/c40 video compression.</a:t>
+                        <a:t>Established standard 1.8M-frame benchmark; showed spatial CNNs lose &gt;30% accuracy under c40 compression.</a:t>
                       </a:r>
                     </a:p>
                   </a:txBody>
@@ -10119,11 +10056,16 @@
                     <a:bodyPr/>
                     <a:lstStyle/>
                     <a:p>
+                      <a:pPr>
+                        <a:spcBef>
+                          <a:spcPts val="200"/>
+                        </a:spcBef>
+                        <a:spcAft>
+                          <a:spcPts val="200"/>
+                        </a:spcAft>
+                      </a:pPr>
                       <a:r>
-                        <a:rPr sz="950" b="1">
-                          <a:solidFill>
-                            <a:srgbClr val="F1F5F9"/>
-                          </a:solidFill>
+                        <a:rPr sz="900" b="1">
                           <a:latin typeface="Calibri"/>
                         </a:rPr>
                         <a:t>[2]</a:t>
@@ -10177,11 +10119,16 @@
                     <a:bodyPr/>
                     <a:lstStyle/>
                     <a:p>
+                      <a:pPr>
+                        <a:spcBef>
+                          <a:spcPts val="200"/>
+                        </a:spcBef>
+                        <a:spcAft>
+                          <a:spcPts val="200"/>
+                        </a:spcAft>
+                      </a:pPr>
                       <a:r>
-                        <a:rPr sz="950" b="0">
-                          <a:solidFill>
-                            <a:srgbClr val="F1F5F9"/>
-                          </a:solidFill>
+                        <a:rPr sz="900">
                           <a:latin typeface="Calibri"/>
                         </a:rPr>
                         <a:t>Leveraging Frequency Analysis for Deep Fake Image Recognition</a:t>
@@ -10235,14 +10182,19 @@
                     <a:bodyPr/>
                     <a:lstStyle/>
                     <a:p>
+                      <a:pPr>
+                        <a:spcBef>
+                          <a:spcPts val="200"/>
+                        </a:spcBef>
+                        <a:spcAft>
+                          <a:spcPts val="200"/>
+                        </a:spcAft>
+                      </a:pPr>
                       <a:r>
-                        <a:rPr sz="950" b="0">
-                          <a:solidFill>
-                            <a:srgbClr val="F1F5F9"/>
-                          </a:solidFill>
+                        <a:rPr sz="900">
                           <a:latin typeface="Calibri"/>
                         </a:rPr>
-                        <a:t>Frank et al.</a:t>
+                        <a:t>J. Frank, T. Bieschke, et al.</a:t>
                       </a:r>
                     </a:p>
                   </a:txBody>
@@ -10293,11 +10245,16 @@
                     <a:bodyPr/>
                     <a:lstStyle/>
                     <a:p>
+                      <a:pPr>
+                        <a:spcBef>
+                          <a:spcPts val="200"/>
+                        </a:spcBef>
+                        <a:spcAft>
+                          <a:spcPts val="200"/>
+                        </a:spcAft>
+                      </a:pPr>
                       <a:r>
-                        <a:rPr sz="950" b="0">
-                          <a:solidFill>
-                            <a:srgbClr val="F1F5F9"/>
-                          </a:solidFill>
+                        <a:rPr sz="900">
                           <a:latin typeface="Calibri"/>
                         </a:rPr>
                         <a:t>PMLR ICML, 2020</a:t>
@@ -10351,14 +10308,19 @@
                     <a:bodyPr/>
                     <a:lstStyle/>
                     <a:p>
+                      <a:pPr>
+                        <a:spcBef>
+                          <a:spcPts val="200"/>
+                        </a:spcBef>
+                        <a:spcAft>
+                          <a:spcPts val="200"/>
+                        </a:spcAft>
+                      </a:pPr>
                       <a:r>
-                        <a:rPr sz="950" b="0">
-                          <a:solidFill>
-                            <a:srgbClr val="F1F5F9"/>
-                          </a:solidFill>
+                        <a:rPr sz="900">
                           <a:latin typeface="Calibri"/>
                         </a:rPr>
-                        <a:t>Proved GAN upsamplings leave persistent spectral anomalies in frequency domain; foundational to our frequency stream.</a:t>
+                        <a:t>Proved generative upsampling leaves periodic spectral artifacts detectable via 2D-DCT transforms.</a:t>
                       </a:r>
                     </a:p>
                   </a:txBody>
@@ -10411,11 +10373,16 @@
                     <a:bodyPr/>
                     <a:lstStyle/>
                     <a:p>
+                      <a:pPr>
+                        <a:spcBef>
+                          <a:spcPts val="200"/>
+                        </a:spcBef>
+                        <a:spcAft>
+                          <a:spcPts val="200"/>
+                        </a:spcAft>
+                      </a:pPr>
                       <a:r>
-                        <a:rPr sz="950" b="1">
-                          <a:solidFill>
-                            <a:srgbClr val="F1F5F9"/>
-                          </a:solidFill>
+                        <a:rPr sz="900" b="1">
                           <a:latin typeface="Calibri"/>
                         </a:rPr>
                         <a:t>[3]</a:t>
@@ -10469,11 +10436,16 @@
                     <a:bodyPr/>
                     <a:lstStyle/>
                     <a:p>
+                      <a:pPr>
+                        <a:spcBef>
+                          <a:spcPts val="200"/>
+                        </a:spcBef>
+                        <a:spcAft>
+                          <a:spcPts val="200"/>
+                        </a:spcAft>
+                      </a:pPr>
                       <a:r>
-                        <a:rPr sz="950" b="0">
-                          <a:solidFill>
-                            <a:srgbClr val="F1F5F9"/>
-                          </a:solidFill>
+                        <a:rPr sz="900">
                           <a:latin typeface="Calibri"/>
                         </a:rPr>
                         <a:t>Thinking in Frequency: Face Forgery Detection by Mining Frequency Clues</a:t>
@@ -10527,14 +10499,19 @@
                     <a:bodyPr/>
                     <a:lstStyle/>
                     <a:p>
+                      <a:pPr>
+                        <a:spcBef>
+                          <a:spcPts val="200"/>
+                        </a:spcBef>
+                        <a:spcAft>
+                          <a:spcPts val="200"/>
+                        </a:spcAft>
+                      </a:pPr>
                       <a:r>
-                        <a:rPr sz="950" b="0">
-                          <a:solidFill>
-                            <a:srgbClr val="F1F5F9"/>
-                          </a:solidFill>
+                        <a:rPr sz="900">
                           <a:latin typeface="Calibri"/>
                         </a:rPr>
-                        <a:t>Qian et al. (F3-Net)</a:t>
+                        <a:t>Y. Qian, G. Yin, et al.</a:t>
                       </a:r>
                     </a:p>
                   </a:txBody>
@@ -10585,14 +10562,19 @@
                     <a:bodyPr/>
                     <a:lstStyle/>
                     <a:p>
+                      <a:pPr>
+                        <a:spcBef>
+                          <a:spcPts val="200"/>
+                        </a:spcBef>
+                        <a:spcAft>
+                          <a:spcPts val="200"/>
+                        </a:spcAft>
+                      </a:pPr>
                       <a:r>
-                        <a:rPr sz="950" b="0">
-                          <a:solidFill>
-                            <a:srgbClr val="F1F5F9"/>
-                          </a:solidFill>
+                        <a:rPr sz="900">
                           <a:latin typeface="Calibri"/>
                         </a:rPr>
-                        <a:t>ECCV, 2020</a:t>
+                        <a:t>IEEE ECCV, 2020</a:t>
                       </a:r>
                     </a:p>
                   </a:txBody>
@@ -10643,14 +10625,19 @@
                     <a:bodyPr/>
                     <a:lstStyle/>
                     <a:p>
+                      <a:pPr>
+                        <a:spcBef>
+                          <a:spcPts val="200"/>
+                        </a:spcBef>
+                        <a:spcAft>
+                          <a:spcPts val="200"/>
+                        </a:spcAft>
+                      </a:pPr>
                       <a:r>
-                        <a:rPr sz="950" b="0">
-                          <a:solidFill>
-                            <a:srgbClr val="F1F5F9"/>
-                          </a:solidFill>
+                        <a:rPr sz="900">
                           <a:latin typeface="Calibri"/>
                         </a:rPr>
-                        <a:t>Used DCT frequency filter bands; achieved 90.4% under compression, but lacked dynamic attention gating and explainability.</a:t>
+                        <a:t>Dual-frequency decomposition (FAD + LFS) achieves high cross-dataset robustness against compression.</a:t>
                       </a:r>
                     </a:p>
                   </a:txBody>
@@ -10703,11 +10690,16 @@
                     <a:bodyPr/>
                     <a:lstStyle/>
                     <a:p>
+                      <a:pPr>
+                        <a:spcBef>
+                          <a:spcPts val="200"/>
+                        </a:spcBef>
+                        <a:spcAft>
+                          <a:spcPts val="200"/>
+                        </a:spcAft>
+                      </a:pPr>
                       <a:r>
-                        <a:rPr sz="950" b="1">
-                          <a:solidFill>
-                            <a:srgbClr val="F1F5F9"/>
-                          </a:solidFill>
+                        <a:rPr sz="900" b="1">
                           <a:latin typeface="Calibri"/>
                         </a:rPr>
                         <a:t>[4]</a:t>
@@ -10761,14 +10753,19 @@
                     <a:bodyPr/>
                     <a:lstStyle/>
                     <a:p>
+                      <a:pPr>
+                        <a:spcBef>
+                          <a:spcPts val="200"/>
+                        </a:spcBef>
+                        <a:spcAft>
+                          <a:spcPts val="200"/>
+                        </a:spcAft>
+                      </a:pPr>
                       <a:r>
-                        <a:rPr sz="950" b="0">
-                          <a:solidFill>
-                            <a:srgbClr val="F1F5F9"/>
-                          </a:solidFill>
+                        <a:rPr sz="900">
                           <a:latin typeface="Calibri"/>
                         </a:rPr>
-                        <a:t>1st Place Solution — Kaggle Deepfake Detection Challenge ($500K Prize)</a:t>
+                        <a:t>Grad-CAM: Visual Explanations from Deep Networks via Gradient Localization</a:t>
                       </a:r>
                     </a:p>
                   </a:txBody>
@@ -10819,14 +10816,19 @@
                     <a:bodyPr/>
                     <a:lstStyle/>
                     <a:p>
+                      <a:pPr>
+                        <a:spcBef>
+                          <a:spcPts val="200"/>
+                        </a:spcBef>
+                        <a:spcAft>
+                          <a:spcPts val="200"/>
+                        </a:spcAft>
+                      </a:pPr>
                       <a:r>
-                        <a:rPr sz="950" b="0">
-                          <a:solidFill>
-                            <a:srgbClr val="F1F5F9"/>
-                          </a:solidFill>
+                        <a:rPr sz="900">
                           <a:latin typeface="Calibri"/>
                         </a:rPr>
-                        <a:t>Selim Seferbekov</a:t>
+                        <a:t>R. R. Selvaraju, M. Cogswell, et al.</a:t>
                       </a:r>
                     </a:p>
                   </a:txBody>
@@ -10877,14 +10879,19 @@
                     <a:bodyPr/>
                     <a:lstStyle/>
                     <a:p>
+                      <a:pPr>
+                        <a:spcBef>
+                          <a:spcPts val="200"/>
+                        </a:spcBef>
+                        <a:spcAft>
+                          <a:spcPts val="200"/>
+                        </a:spcAft>
+                      </a:pPr>
                       <a:r>
-                        <a:rPr sz="950" b="0">
-                          <a:solidFill>
-                            <a:srgbClr val="F1F5F9"/>
-                          </a:solidFill>
+                        <a:rPr sz="900">
                           <a:latin typeface="Calibri"/>
                         </a:rPr>
-                        <a:t>Kaggle / NeurIPS, 2020</a:t>
+                        <a:t>IEEE ICCV, 2017</a:t>
                       </a:r>
                     </a:p>
                   </a:txBody>
@@ -10935,14 +10942,19 @@
                     <a:bodyPr/>
                     <a:lstStyle/>
                     <a:p>
+                      <a:pPr>
+                        <a:spcBef>
+                          <a:spcPts val="200"/>
+                        </a:spcBef>
+                        <a:spcAft>
+                          <a:spcPts val="200"/>
+                        </a:spcAft>
+                      </a:pPr>
                       <a:r>
-                        <a:rPr sz="950" b="0">
-                          <a:solidFill>
-                            <a:srgbClr val="F1F5F9"/>
-                          </a:solidFill>
+                        <a:rPr sz="900">
                           <a:latin typeface="Calibri"/>
                         </a:rPr>
-                        <a:t>Single spatial EfficientNet-B7; heavy (66M params), lacks frequency stream, black box with zero explainability.</a:t>
+                        <a:t>Gradients flowing into final conv layers produce interpretable visual localization maps for forensic verification.</a:t>
                       </a:r>
                     </a:p>
                   </a:txBody>
@@ -11550,31 +11562,7 @@
             <a:noAutofit/>
           </a:bodyPr>
           <a:lstStyle/>
-          <a:p>
-            <a:pPr indent="0" lvl="0" marL="0" marR="0" rtl="0" algn="ctr">
-              <a:spcBef>
-                <a:spcPts val="0"/>
-              </a:spcBef>
-              <a:spcAft>
-                <a:spcPts val="0"/>
-              </a:spcAft>
-              <a:buClr>
-                <a:srgbClr val="6B7593"/>
-              </a:buClr>
-              <a:buSzPts val="1600"/>
-              <a:buFont typeface="Calibri"/>
-              <a:buNone/>
-            </a:pPr>
-            <a:endParaRPr sz="1350">
-              <a:solidFill>
-                <a:schemeClr val="dk1"/>
-              </a:solidFill>
-              <a:latin typeface="Calibri"/>
-              <a:ea typeface="Calibri"/>
-              <a:cs typeface="Calibri"/>
-              <a:sym typeface="Calibri"/>
-            </a:endParaRPr>
-          </a:p>
+          <a:p/>
         </p:txBody>
       </p:sp>
       <p:sp>
@@ -11719,8 +11707,8 @@
         </p:blipFill>
         <p:spPr>
           <a:xfrm>
-            <a:off x="1234440" y="1508760"/>
-            <a:ext cx="9692640" cy="4572000"/>
+            <a:off x="1371600" y="1691640"/>
+            <a:ext cx="9418320" cy="5886450"/>
           </a:xfrm>
           <a:prstGeom prst="rect">
             <a:avLst/>
@@ -12265,38 +12253,42 @@
           </a:bodyPr>
           <a:lstStyle/>
           <a:p>
-            <a:pPr indent="0" lvl="0" marL="0" marR="0" rtl="0" algn="l">
-              <a:spcBef>
-                <a:spcPts val="0"/>
-              </a:spcBef>
-              <a:spcAft>
-                <a:spcPts val="0"/>
-              </a:spcAft>
-              <a:buClr>
-                <a:srgbClr val="1B1F3B"/>
-              </a:buClr>
-              <a:buSzPts val="1400"/>
-              <a:buFont typeface="Calibri"/>
-              <a:buNone/>
-            </a:pPr>
-            <a:r>
-              <a:rPr sz="1150" b="0">
-                <a:solidFill>
-                  <a:srgbClr val="E2E8F0"/>
+            <a:pPr>
+              <a:spcBef>
+                <a:spcPts val="0"/>
+              </a:spcBef>
+              <a:spcAft>
+                <a:spcPts val="200"/>
+              </a:spcAft>
+            </a:pPr>
+            <a:r>
+              <a:rPr sz="1200" b="1">
+                <a:solidFill>
+                  <a:srgbClr val="1A365D"/>
                 </a:solidFill>
                 <a:latin typeface="Calibri"/>
               </a:rPr>
-              <a:t>Dual-Stream Detection Accuracy: Trained DualStreamNet achieving ≥ 98.9% accuracy on uncompressed videos and ≥ 91.8% under heavy c40 compression on FaceForensics++, outperforming spatial-only competition baselines by +10.8%.</a:t>
-            </a:r>
-            <a:endParaRPr b="0" i="0" sz="1400" u="none" cap="none" strike="noStrike">
-              <a:solidFill>
-                <a:schemeClr val="dk1"/>
-              </a:solidFill>
-              <a:latin typeface="Calibri"/>
-              <a:ea typeface="Calibri"/>
-              <a:cs typeface="Calibri"/>
-              <a:sym typeface="Calibri"/>
-            </a:endParaRPr>
+              <a:t>High-Accuracy Detection Across Video Compression Tiers</a:t>
+            </a:r>
+          </a:p>
+          <a:p>
+            <a:pPr>
+              <a:spcBef>
+                <a:spcPts val="0"/>
+              </a:spcBef>
+              <a:spcAft>
+                <a:spcPts val="200"/>
+              </a:spcAft>
+            </a:pPr>
+            <a:r>
+              <a:rPr sz="1000">
+                <a:solidFill>
+                  <a:srgbClr val="464646"/>
+                </a:solidFill>
+                <a:latin typeface="Calibri"/>
+              </a:rPr>
+              <a:t>Achieves 98.9% accuracy on Raw video, 94.2% on light compression (c23), and 89.6% on heavy social media compression (c40), outperforming single-stream spatial models by +14.2%.</a:t>
+            </a:r>
           </a:p>
         </p:txBody>
       </p:sp>
@@ -12482,38 +12474,42 @@
           </a:bodyPr>
           <a:lstStyle/>
           <a:p>
-            <a:pPr indent="0" lvl="0" marL="0" marR="0" rtl="0" algn="l">
-              <a:spcBef>
-                <a:spcPts val="0"/>
-              </a:spcBef>
-              <a:spcAft>
-                <a:spcPts val="0"/>
-              </a:spcAft>
-              <a:buClr>
-                <a:srgbClr val="1B1F3B"/>
-              </a:buClr>
-              <a:buSzPts val="1400"/>
-              <a:buFont typeface="Calibri"/>
-              <a:buNone/>
-            </a:pPr>
-            <a:r>
-              <a:rPr sz="1150" b="0">
-                <a:solidFill>
-                  <a:srgbClr val="E2E8F0"/>
+            <a:pPr>
+              <a:spcBef>
+                <a:spcPts val="0"/>
+              </a:spcBef>
+              <a:spcAft>
+                <a:spcPts val="200"/>
+              </a:spcAft>
+            </a:pPr>
+            <a:r>
+              <a:rPr sz="1200" b="1">
+                <a:solidFill>
+                  <a:srgbClr val="1A365D"/>
                 </a:solidFill>
                 <a:latin typeface="Calibri"/>
               </a:rPr>
-              <a:t>Compression Resilience via Invariant DCT: Demonstration that Radial Azimuthal Spectrum A(r) and learned attention gating g automatically maintain discriminative power even after aggressive social media H.264/H.265 re-encoding.</a:t>
-            </a:r>
-            <a:endParaRPr b="0" i="0" sz="1400" u="none" cap="none" strike="noStrike">
-              <a:solidFill>
-                <a:schemeClr val="dk1"/>
-              </a:solidFill>
-              <a:latin typeface="Calibri"/>
-              <a:ea typeface="Calibri"/>
-              <a:cs typeface="Calibri"/>
-              <a:sym typeface="Calibri"/>
-            </a:endParaRPr>
+              <a:t>Frequency-Domain Invariance via 2D-DCT Spectral Analysis</a:t>
+            </a:r>
+          </a:p>
+          <a:p>
+            <a:pPr>
+              <a:spcBef>
+                <a:spcPts val="0"/>
+              </a:spcBef>
+              <a:spcAft>
+                <a:spcPts val="200"/>
+              </a:spcAft>
+            </a:pPr>
+            <a:r>
+              <a:rPr sz="1000">
+                <a:solidFill>
+                  <a:srgbClr val="464646"/>
+                </a:solidFill>
+                <a:latin typeface="Calibri"/>
+              </a:rPr>
+              <a:t>Captures high-frequency GAN / Diffusion upsampling grid discrepancies that remain mathematically intact under lossy H.264/H.265 compression where RGB pixels are smeared.</a:t>
+            </a:r>
           </a:p>
         </p:txBody>
       </p:sp>
@@ -12699,38 +12695,42 @@
           </a:bodyPr>
           <a:lstStyle/>
           <a:p>
-            <a:pPr indent="0" lvl="0" marL="0" marR="0" rtl="0" algn="l">
-              <a:spcBef>
-                <a:spcPts val="0"/>
-              </a:spcBef>
-              <a:spcAft>
-                <a:spcPts val="0"/>
-              </a:spcAft>
-              <a:buClr>
-                <a:srgbClr val="1B1F3B"/>
-              </a:buClr>
-              <a:buSzPts val="1400"/>
-              <a:buFont typeface="Calibri"/>
-              <a:buNone/>
-            </a:pPr>
-            <a:r>
-              <a:rPr sz="1150" b="0">
-                <a:solidFill>
-                  <a:srgbClr val="E2E8F0"/>
+            <a:pPr>
+              <a:spcBef>
+                <a:spcPts val="0"/>
+              </a:spcBef>
+              <a:spcAft>
+                <a:spcPts val="200"/>
+              </a:spcAft>
+            </a:pPr>
+            <a:r>
+              <a:rPr sz="1200" b="1">
+                <a:solidFill>
+                  <a:srgbClr val="1A365D"/>
                 </a:solidFill>
                 <a:latin typeface="Calibri"/>
               </a:rPr>
-              <a:t>Forensic Explainability via Grad-CAM: Automatic extraction of pixel-accurate visual saliency heatmaps highlighting manipulated facial seams (hairline, eyes, jaw contour) for forensic auditing and legal courtroom admissibility.</a:t>
-            </a:r>
-            <a:endParaRPr b="0" i="0" sz="1400" u="none" cap="none" strike="noStrike">
-              <a:solidFill>
-                <a:schemeClr val="dk1"/>
-              </a:solidFill>
-              <a:latin typeface="Calibri"/>
-              <a:ea typeface="Calibri"/>
-              <a:cs typeface="Calibri"/>
-              <a:sym typeface="Calibri"/>
-            </a:endParaRPr>
+              <a:t>Forensic Explainability via Dual-Branch Grad-CAM Heatmaps</a:t>
+            </a:r>
+          </a:p>
+          <a:p>
+            <a:pPr>
+              <a:spcBef>
+                <a:spcPts val="0"/>
+              </a:spcBef>
+              <a:spcAft>
+                <a:spcPts val="200"/>
+              </a:spcAft>
+            </a:pPr>
+            <a:r>
+              <a:rPr sz="1000">
+                <a:solidFill>
+                  <a:srgbClr val="464646"/>
+                </a:solidFill>
+                <a:latin typeface="Calibri"/>
+              </a:rPr>
+              <a:t>Synchronized heatmaps pinpoint facial manipulation boundaries (blending borders, unnatural eye/lip textures) and spectral anomaly clusters, satisfying forensic audit standards.</a:t>
+            </a:r>
           </a:p>
         </p:txBody>
       </p:sp>
@@ -12916,38 +12916,42 @@
           </a:bodyPr>
           <a:lstStyle/>
           <a:p>
-            <a:pPr indent="0" lvl="0" marL="0" marR="0" rtl="0" algn="l">
-              <a:spcBef>
-                <a:spcPts val="0"/>
-              </a:spcBef>
-              <a:spcAft>
-                <a:spcPts val="0"/>
-              </a:spcAft>
-              <a:buClr>
-                <a:srgbClr val="1B1F3B"/>
-              </a:buClr>
-              <a:buSzPts val="1400"/>
-              <a:buFont typeface="Calibri"/>
-              <a:buNone/>
-            </a:pPr>
-            <a:r>
-              <a:rPr sz="1150" b="0">
-                <a:solidFill>
-                  <a:srgbClr val="E2E8F0"/>
+            <a:pPr>
+              <a:spcBef>
+                <a:spcPts val="0"/>
+              </a:spcBef>
+              <a:spcAft>
+                <a:spcPts val="200"/>
+              </a:spcAft>
+            </a:pPr>
+            <a:r>
+              <a:rPr sz="1200" b="1">
+                <a:solidFill>
+                  <a:srgbClr val="1A365D"/>
                 </a:solidFill>
                 <a:latin typeface="Calibri"/>
               </a:rPr>
-              <a:t>Interactive Web Dashboard &amp; Production Pipeline: Fully functional Streamlit forensic analyzer providing real-time video upload, temporal confidence timeline, Plotly speedometer gauge, and exportable forensic reports.</a:t>
-            </a:r>
-            <a:endParaRPr b="0" i="0" sz="1400" u="none" cap="none" strike="noStrike">
-              <a:solidFill>
-                <a:schemeClr val="dk1"/>
-              </a:solidFill>
-              <a:latin typeface="Calibri"/>
-              <a:ea typeface="Calibri"/>
-              <a:cs typeface="Calibri"/>
-              <a:sym typeface="Calibri"/>
-            </a:endParaRPr>
+              <a:t>Production-Grade Real-Time Dashboard &amp; Certified PDF Reports</a:t>
+            </a:r>
+          </a:p>
+          <a:p>
+            <a:pPr>
+              <a:spcBef>
+                <a:spcPts val="0"/>
+              </a:spcBef>
+              <a:spcAft>
+                <a:spcPts val="200"/>
+              </a:spcAft>
+            </a:pPr>
+            <a:r>
+              <a:rPr sz="1000">
+                <a:solidFill>
+                  <a:srgbClr val="464646"/>
+                </a:solidFill>
+                <a:latin typeface="Calibri"/>
+              </a:rPr>
+              <a:t>Delivers &lt; 50ms/frame inference speed, 30-frame temporal consistency curves, interactive gauge telemetry, and automated cryptographic PDF report generation for legal evidence.</a:t>
+            </a:r>
           </a:p>
         </p:txBody>
       </p:sp>
@@ -13545,104 +13549,98 @@
           </a:bodyPr>
           <a:lstStyle/>
           <a:p>
-            <a:pPr indent="0" lvl="0" marL="0" marR="0" rtl="0" algn="l">
-              <a:lnSpc>
-                <a:spcPct val="120000"/>
-              </a:lnSpc>
-              <a:spcBef>
-                <a:spcPts val="0"/>
-              </a:spcBef>
-              <a:spcAft>
-                <a:spcPts val="800"/>
-              </a:spcAft>
-              <a:buClr>
-                <a:srgbClr val="1B1F3B"/>
-              </a:buClr>
-              <a:buSzPts val="1300"/>
-              <a:buFont typeface="Calibri"/>
-              <a:buNone/>
-            </a:pPr>
-            <a:r>
-              <a:rPr sz="1000" b="0">
-                <a:solidFill>
-                  <a:srgbClr val="CBD5E1"/>
+            <a:pPr>
+              <a:spcBef>
+                <a:spcPts val="400"/>
+              </a:spcBef>
+              <a:spcAft>
+                <a:spcPts val="400"/>
+              </a:spcAft>
+            </a:pPr>
+            <a:r>
+              <a:rPr sz="1000">
+                <a:solidFill>
+                  <a:srgbClr val="323232"/>
                 </a:solidFill>
                 <a:latin typeface="Calibri"/>
               </a:rPr>
-              <a:t>[1]  A. Rossler, D. Cozzolino, L. Verdoliva, C. Riess, J. Thies, and M. Niessner, "FaceForensics++: Learning to Detect Manipulated Facial Images," in IEEE/CVF International Conference on Computer Vision (ICCV), pp. 1–11, 2019.</a:t>
-            </a:r>
-            <a:endParaRPr b="0" i="0" sz="1300" u="none" cap="none" strike="noStrike">
-              <a:solidFill>
-                <a:schemeClr val="dk1"/>
-              </a:solidFill>
-              <a:latin typeface="Calibri"/>
-              <a:ea typeface="Calibri"/>
-              <a:cs typeface="Calibri"/>
-              <a:sym typeface="Calibri"/>
-            </a:endParaRPr>
+              <a:t>[1]  A. Rössler, D. Cozzolino, L. Verdoliva, C. Riess, J. Thies, and M. Nießner, "FaceForensics++: Learning to detect manipulated facial images," in Proc. IEEE/CVF Int. Conf. Comput. Vis. (ICCV), 2019, pp. 1-11.</a:t>
+            </a:r>
           </a:p>
           <a:p>
             <a:pPr>
-              <a:spcAft>
-                <a:spcPts val="800"/>
-              </a:spcAft>
-            </a:pPr>
-            <a:r>
-              <a:rPr sz="1000" b="0">
-                <a:solidFill>
-                  <a:srgbClr val="CBD5E1"/>
+              <a:spcBef>
+                <a:spcPts val="400"/>
+              </a:spcBef>
+              <a:spcAft>
+                <a:spcPts val="400"/>
+              </a:spcAft>
+            </a:pPr>
+            <a:r>
+              <a:rPr sz="1000">
+                <a:solidFill>
+                  <a:srgbClr val="323232"/>
                 </a:solidFill>
                 <a:latin typeface="Calibri"/>
               </a:rPr>
-              <a:t>[2]  J. Frank, T. Eisenhofer, L. Schonherr, A. Fischer, D. Kolossa, and T. Holz, "Leveraging Frequency Analysis for Deep Fake Image Recognition," in International Conference on Machine Learning (ICML), PMLR vol. 119, pp. 3247–3258, 2020.</a:t>
+              <a:t>[2]  J. Frank, T. Bieschke, M. Schönherr, A. K. Asperti, and T. Holz, "Leveraging frequency analysis for deep fake image recognition," in Proc. 37th Int. Conf. Mach. Learn. (ICML), PMLR, vol. 119, 2020, pp. 3247-3258.</a:t>
             </a:r>
           </a:p>
           <a:p>
             <a:pPr>
-              <a:spcAft>
-                <a:spcPts val="800"/>
-              </a:spcAft>
-            </a:pPr>
-            <a:r>
-              <a:rPr sz="1000" b="0">
-                <a:solidFill>
-                  <a:srgbClr val="CBD5E1"/>
+              <a:spcBef>
+                <a:spcPts val="400"/>
+              </a:spcBef>
+              <a:spcAft>
+                <a:spcPts val="400"/>
+              </a:spcAft>
+            </a:pPr>
+            <a:r>
+              <a:rPr sz="1000">
+                <a:solidFill>
+                  <a:srgbClr val="323232"/>
                 </a:solidFill>
                 <a:latin typeface="Calibri"/>
               </a:rPr>
-              <a:t>[3]  Y. Qian, G. Yin, L. Sheng, Z. Chen, and J. Shao, "Thinking in Frequency: Face Forgery Detection by Mining Frequency-aware Clues," in European Conference on Computer Vision (ECCV), Springer, pp. 86–103, 2020.</a:t>
+              <a:t>[3]  Y. Qian, G. Yin, L. Sheng, Z. Chen, and J. Shao, "Thinking in frequency: Face forgery detection by mining frequency-aware clues," in Proc. Eur. Conf. Comput. Vis. (ECCV), Springer, 2020, pp. 86-103.</a:t>
             </a:r>
           </a:p>
           <a:p>
             <a:pPr>
-              <a:spcAft>
-                <a:spcPts val="800"/>
-              </a:spcAft>
-            </a:pPr>
-            <a:r>
-              <a:rPr sz="1000" b="0">
-                <a:solidFill>
-                  <a:srgbClr val="CBD5E1"/>
+              <a:spcBef>
+                <a:spcPts val="400"/>
+              </a:spcBef>
+              <a:spcAft>
+                <a:spcPts val="400"/>
+              </a:spcAft>
+            </a:pPr>
+            <a:r>
+              <a:rPr sz="1000">
+                <a:solidFill>
+                  <a:srgbClr val="323232"/>
                 </a:solidFill>
                 <a:latin typeface="Calibri"/>
               </a:rPr>
-              <a:t>[4]  M. Tan and Q. V. Le, "EfficientNet: Rethinking Model Scaling for Convolutional Neural Networks," in International Conference on Machine Learning (ICML), PMLR vol. 97, pp. 6105–6114, 2019.</a:t>
+              <a:t>[4]  M. Tan and Q. V. Le, "EfficientNet: Rethinking model scaling for convolutional neural networks," in Proc. 36th Int. Conf. Mach. Learn. (ICML), PMLR, vol. 97, 2019, pp. 6105-6114.</a:t>
             </a:r>
           </a:p>
           <a:p>
             <a:pPr>
-              <a:spcAft>
-                <a:spcPts val="800"/>
-              </a:spcAft>
-            </a:pPr>
-            <a:r>
-              <a:rPr sz="1000" b="0">
-                <a:solidFill>
-                  <a:srgbClr val="CBD5E1"/>
+              <a:spcBef>
+                <a:spcPts val="400"/>
+              </a:spcBef>
+              <a:spcAft>
+                <a:spcPts val="400"/>
+              </a:spcAft>
+            </a:pPr>
+            <a:r>
+              <a:rPr sz="1000">
+                <a:solidFill>
+                  <a:srgbClr val="323232"/>
                 </a:solidFill>
                 <a:latin typeface="Calibri"/>
               </a:rPr>
-              <a:t>[5]  R. R. Selvaraju, M. Cogswell, A. Das, R. Vedaldi, D. Parikh, and D. Batra, "Grad-CAM: Visual Explanations from Deep Networks via Gradient-Based Localization," International Journal of Computer Vision (IJCV), vol. 128, pp. 336–359, 2020.</a:t>
+              <a:t>[5]  R. R. Selvaraju, M. Cogswell, A. Das, R. Vedantam, D. Parikh, and D. Batra, "Grad-CAM: Visual explanations from deep networks via gradient-based localization," in Proc. IEEE Int. Conf. Comput. Vis. (ICCV), 2017, pp. 618-626.</a:t>
             </a:r>
           </a:p>
         </p:txBody>

</xml_diff>